<commit_message>
Resultados de oclusion, falsos disparos de E3 y speech de la pregunta 3
- results/oclusion: 300 cajas etiquetadas (bajo/medio/alto/saltada)
- informe: tabla y analisis de recall por oclusion, falsos disparos de E3 en validacion
- presentacion: diapositiva 16 con resultados y speech de 8 minutos
- tamano_oclusion.py: titulo de la figura de oclusion

Co-Authored-By: Claude Opus 5.5 <noreply@anthropic.com>
</commit_message>
<xml_diff>
--- a/presentacion/presentacion_pregunta3_grupo6.pptx
+++ b/presentacion/presentacion_pregunta3_grupo6.pptx
@@ -2611,6 +2611,380 @@
                 </a:solidFill>
                 <a:latin typeface="Calibri"/>
               </a:rPr>
+              <a:t>Recall por nivel de oclusión</a:t>
+            </a:r>
+          </a:p>
+        </c:rich>
+      </c:tx>
+      <c:layout/>
+      <c:overlay val="0"/>
+    </c:title>
+    <c:autoTitleDeleted val="0"/>
+    <c:plotArea>
+      <c:layout/>
+      <c:barChart>
+        <c:barDir val="col"/>
+        <c:grouping val="clustered"/>
+        <c:varyColors val="0"/>
+        <c:ser>
+          <c:idx val="0"/>
+          <c:order val="0"/>
+          <c:tx>
+            <c:strRef>
+              <c:f>Sheet1!$B$1</c:f>
+              <c:strCache>
+                <c:ptCount val="1"/>
+                <c:pt idx="0">
+                  <c:v>cis_test</c:v>
+                </c:pt>
+              </c:strCache>
+            </c:strRef>
+          </c:tx>
+          <c:spPr>
+            <a:solidFill>
+              <a:srgbClr val="2E7D32"/>
+            </a:solidFill>
+            <a:effectLst/>
+          </c:spPr>
+          <c:invertIfNegative val="0"/>
+          <c:dLbls>
+            <c:numFmt formatCode="0.00" sourceLinked="0"/>
+            <c:txPr>
+              <a:bodyPr/>
+              <a:lstStyle/>
+              <a:p>
+                <a:pPr>
+                  <a:defRPr b="0" i="0" strike="noStrike" sz="1000" u="none">
+                    <a:solidFill>
+                      <a:srgbClr val="222222"/>
+                    </a:solidFill>
+                    <a:latin typeface="Calibri"/>
+                  </a:defRPr>
+                </a:pPr>
+              </a:p>
+            </c:txPr>
+            <c:showLegendKey val="0"/>
+            <c:showVal val="1"/>
+            <c:showCatName val="0"/>
+            <c:showSerName val="0"/>
+            <c:showPercent val="0"/>
+            <c:showBubbleSize val="0"/>
+            <c:showLeaderLines val="0"/>
+          </c:dLbls>
+          <c:cat>
+            <c:multiLvlStrRef>
+              <c:f>Sheet1!$A$2:$A$4</c:f>
+              <c:multiLvlStrCache>
+                <c:ptCount val="3"/>
+                <c:lvl>
+                  <c:pt idx="0">
+                    <c:v>baja (n 96 / 76)</c:v>
+                  </c:pt>
+                  <c:pt idx="1">
+                    <c:v>media (n 43 / 46)</c:v>
+                  </c:pt>
+                  <c:pt idx="2">
+                    <c:v>alta (n 2 / 10)</c:v>
+                  </c:pt>
+                </c:lvl>
+              </c:multiLvlStrCache>
+            </c:multiLvlStrRef>
+          </c:cat>
+          <c:val>
+            <c:numRef>
+              <c:f>Sheet1!$B$2:$B$4</c:f>
+              <c:numCache>
+                <c:formatCode>General</c:formatCode>
+                <c:ptCount val="3"/>
+                <c:pt idx="0">
+                  <c:v>0.906</c:v>
+                </c:pt>
+                <c:pt idx="1">
+                  <c:v>0.744</c:v>
+                </c:pt>
+                <c:pt idx="2">
+                  <c:v>0.5</c:v>
+                </c:pt>
+              </c:numCache>
+            </c:numRef>
+          </c:val>
+        </c:ser>
+        <c:ser>
+          <c:idx val="1"/>
+          <c:order val="1"/>
+          <c:tx>
+            <c:strRef>
+              <c:f>Sheet1!$C$1</c:f>
+              <c:strCache>
+                <c:ptCount val="1"/>
+                <c:pt idx="0">
+                  <c:v>trans_test</c:v>
+                </c:pt>
+              </c:strCache>
+            </c:strRef>
+          </c:tx>
+          <c:spPr>
+            <a:solidFill>
+              <a:srgbClr val="7A1518"/>
+            </a:solidFill>
+            <a:effectLst/>
+          </c:spPr>
+          <c:invertIfNegative val="0"/>
+          <c:dLbls>
+            <c:numFmt formatCode="0.00" sourceLinked="0"/>
+            <c:txPr>
+              <a:bodyPr/>
+              <a:lstStyle/>
+              <a:p>
+                <a:pPr>
+                  <a:defRPr b="0" i="0" strike="noStrike" sz="1000" u="none">
+                    <a:solidFill>
+                      <a:srgbClr val="222222"/>
+                    </a:solidFill>
+                    <a:latin typeface="Calibri"/>
+                  </a:defRPr>
+                </a:pPr>
+              </a:p>
+            </c:txPr>
+            <c:showLegendKey val="0"/>
+            <c:showVal val="1"/>
+            <c:showCatName val="0"/>
+            <c:showSerName val="0"/>
+            <c:showPercent val="0"/>
+            <c:showBubbleSize val="0"/>
+            <c:showLeaderLines val="0"/>
+          </c:dLbls>
+          <c:cat>
+            <c:multiLvlStrRef>
+              <c:f>Sheet1!$A$2:$A$4</c:f>
+              <c:multiLvlStrCache>
+                <c:ptCount val="3"/>
+                <c:lvl>
+                  <c:pt idx="0">
+                    <c:v>baja (n 96 / 76)</c:v>
+                  </c:pt>
+                  <c:pt idx="1">
+                    <c:v>media (n 43 / 46)</c:v>
+                  </c:pt>
+                  <c:pt idx="2">
+                    <c:v>alta (n 2 / 10)</c:v>
+                  </c:pt>
+                </c:lvl>
+              </c:multiLvlStrCache>
+            </c:multiLvlStrRef>
+          </c:cat>
+          <c:val>
+            <c:numRef>
+              <c:f>Sheet1!$C$2:$C$4</c:f>
+              <c:numCache>
+                <c:formatCode>General</c:formatCode>
+                <c:ptCount val="3"/>
+                <c:pt idx="0">
+                  <c:v>0.816</c:v>
+                </c:pt>
+                <c:pt idx="1">
+                  <c:v>0.522</c:v>
+                </c:pt>
+                <c:pt idx="2">
+                  <c:v>0.1</c:v>
+                </c:pt>
+              </c:numCache>
+            </c:numRef>
+          </c:val>
+        </c:ser>
+        <c:dLbls>
+          <c:numFmt formatCode="0.00" sourceLinked="0"/>
+          <c:txPr>
+            <a:bodyPr/>
+            <a:lstStyle/>
+            <a:p>
+              <a:pPr>
+                <a:defRPr b="0" i="0" strike="noStrike" sz="1000" u="none">
+                  <a:solidFill>
+                    <a:srgbClr val="222222"/>
+                  </a:solidFill>
+                  <a:latin typeface="Calibri"/>
+                </a:defRPr>
+              </a:pPr>
+            </a:p>
+          </c:txPr>
+          <c:showLegendKey val="0"/>
+          <c:showVal val="1"/>
+          <c:showCatName val="0"/>
+          <c:showSerName val="0"/>
+          <c:showPercent val="0"/>
+          <c:showBubbleSize val="0"/>
+          <c:showLeaderLines val="0"/>
+        </c:dLbls>
+        <c:gapWidth val="60"/>
+        <c:overlap val="0"/>
+        <c:axId val="2094734554"/>
+        <c:axId val="2094734552"/>
+        <c:axId val="2094734556"/>
+      </c:barChart>
+      <c:catAx>
+        <c:axId val="2094734554"/>
+        <c:scaling>
+          <c:orientation val="minMax"/>
+        </c:scaling>
+        <c:delete val="0"/>
+        <c:axPos val="b"/>
+        <c:numFmt formatCode="General" sourceLinked="1"/>
+        <c:majorTickMark val="out"/>
+        <c:minorTickMark val="none"/>
+        <c:tickLblPos val="low"/>
+        <c:spPr>
+          <a:ln w="12700" cap="flat">
+            <a:solidFill>
+              <a:srgbClr val="888888"/>
+            </a:solidFill>
+            <a:prstDash val="solid"/>
+            <a:round/>
+          </a:ln>
+        </c:spPr>
+        <c:txPr>
+          <a:bodyPr/>
+          <a:lstStyle/>
+          <a:p>
+            <a:pPr>
+              <a:defRPr sz="1100" b="0" i="0" u="none" strike="noStrike">
+                <a:solidFill>
+                  <a:srgbClr val="5A5A5A"/>
+                </a:solidFill>
+                <a:latin typeface="Calibri"/>
+              </a:defRPr>
+            </a:pPr>
+            <a:endParaRPr lang="en-US"/>
+          </a:p>
+        </c:txPr>
+        <c:crossAx val="2094734552"/>
+        <c:crosses val="autoZero"/>
+        <c:auto val="1"/>
+        <c:lblAlgn val="ctr"/>
+        <c:noMultiLvlLbl val="1"/>
+      </c:catAx>
+      <c:valAx>
+        <c:axId val="2094734552"/>
+        <c:scaling>
+          <c:orientation val="minMax"/>
+          <c:max val="1"/>
+          <c:min val="0"/>
+        </c:scaling>
+        <c:delete val="0"/>
+        <c:axPos val="l"/>
+        <c:majorGridlines>
+          <c:spPr>
+            <a:ln w="6350" cap="flat">
+              <a:solidFill>
+                <a:srgbClr val="E6E6E6"/>
+              </a:solidFill>
+              <a:prstDash val="solid"/>
+              <a:round/>
+            </a:ln>
+          </c:spPr>
+        </c:majorGridlines>
+        <c:numFmt formatCode="General" sourceLinked="0"/>
+        <c:majorTickMark val="out"/>
+        <c:minorTickMark val="none"/>
+        <c:tickLblPos val="nextTo"/>
+        <c:spPr>
+          <a:ln w="12700" cap="flat">
+            <a:solidFill>
+              <a:srgbClr val="888888"/>
+            </a:solidFill>
+            <a:prstDash val="solid"/>
+            <a:round/>
+          </a:ln>
+        </c:spPr>
+        <c:txPr>
+          <a:bodyPr/>
+          <a:lstStyle/>
+          <a:p>
+            <a:pPr>
+              <a:defRPr sz="1000" b="0" i="0" u="none" strike="noStrike">
+                <a:solidFill>
+                  <a:srgbClr val="5A5A5A"/>
+                </a:solidFill>
+                <a:latin typeface="Calibri"/>
+              </a:defRPr>
+            </a:pPr>
+            <a:endParaRPr lang="en-US"/>
+          </a:p>
+        </c:txPr>
+        <c:crossAx val="2094734554"/>
+        <c:crosses val="autoZero"/>
+        <c:crossBetween val="between"/>
+      </c:valAx>
+      <c:spPr>
+        <a:noFill/>
+        <a:ln>
+          <a:noFill/>
+        </a:ln>
+        <a:effectLst/>
+      </c:spPr>
+    </c:plotArea>
+    <c:legend>
+      <c:legendPos val="t"/>
+      <c:overlay val="0"/>
+      <c:txPr>
+        <a:bodyPr/>
+        <a:lstStyle/>
+        <a:p>
+          <a:pPr>
+            <a:defRPr sz="1100">
+              <a:solidFill>
+                <a:srgbClr val="222222"/>
+              </a:solidFill>
+              <a:latin typeface="Calibri"/>
+              <a:cs typeface="Calibri"/>
+            </a:defRPr>
+          </a:pPr>
+          <a:endParaRPr lang="en-US"/>
+        </a:p>
+      </c:txPr>
+    </c:legend>
+    <c:plotVisOnly val="1"/>
+    <c:dispBlanksAs val="span"/>
+  </c:chart>
+  <c:spPr>
+    <a:noFill/>
+    <a:ln>
+      <a:noFill/>
+    </a:ln>
+    <a:effectLst/>
+  </c:spPr>
+  <c:externalData r:id="rId1">
+    <c:autoUpdate val="0"/>
+  </c:externalData>
+</c:chartSpace>
+</file>
+
+<file path=ppt/charts/chart8.xml><?xml version="1.0" encoding="utf-8"?>
+<c:chartSpace xmlns:c="http://schemas.openxmlformats.org/drawingml/2006/chart" xmlns:a="http://schemas.openxmlformats.org/drawingml/2006/main" xmlns:r="http://schemas.openxmlformats.org/officeDocument/2006/relationships">
+  <c:date1904 val="0"/>
+  <c:roundedCorners val="1"/>
+  <c:chart>
+    <c:title>
+      <c:tx>
+        <c:rich>
+          <a:bodyPr/>
+          <a:lstStyle/>
+          <a:p>
+            <a:pPr>
+              <a:defRPr sz="1300" b="0" i="0" u="none" strike="noStrike">
+                <a:solidFill>
+                  <a:srgbClr val="222222"/>
+                </a:solidFill>
+                <a:latin typeface="Calibri"/>
+              </a:defRPr>
+            </a:pPr>
+            <a:r>
+              <a:rPr sz="1300" b="0" i="0" u="none" strike="noStrike">
+                <a:solidFill>
+                  <a:srgbClr val="222222"/>
+                </a:solidFill>
+                <a:latin typeface="Calibri"/>
+              </a:rPr>
               <a:t>Eventos por especie en la cámara 46</a:t>
             </a:r>
           </a:p>
@@ -4040,7 +4414,7 @@
           <a:p>
             <a:r>
               <a:rPr lang="en-US" dirty="0"/>
-              <a:t>CCT-20 no trae información de oclusión, así que construimos una herramienta para etiquetarla. Se muestran 150 cajas por split de test a resolución completa y se asigna un nivel con una tecla. Para medir la consistencia del etiquetado, re-etiquetamos 50 cajas sin ver la etiqueta anterior y calculamos kappa de Cohen. [Completar con los resultados del etiquetado.]</a:t>
+              <a:t>CCT-20 no trae información de oclusión, así que armamos una muestra de 150 cajas por split y le asignamos a cada una un nivel según qué parte del animal no se ve. Por tiempo, el etiquetado inicial lo hizo un modelo de visión siguiendo el criterio, y una persona re-etiqueta 50 cajas a ciegas para medir el acuerdo. El resultado es claro: con oclusión baja el recall es 0,91 en cis y 0,82 en trans; con oclusión media cae a 0,74 y 0,52. Ver solo una parte del animal ya es difícil, y en una cámara nueva lo es mucho más. La oclusión alta tiene muy pocos casos, solo marca la tendencia.</a:t>
             </a:r>
             <a:endParaRPr lang="en-US" dirty="0"/>
           </a:p>
@@ -9744,7 +10118,7 @@
                 <a:ea typeface="Cambria" pitchFamily="34" charset="-122"/>
                 <a:cs typeface="Cambria" pitchFamily="34" charset="-120"/>
               </a:rPr>
-              <a:t>E4 · CCT-20 no anota la oclusión: la etiquetamos a mano</a:t>
+              <a:t>E4 · Cuanto más oculto el animal, peor; y en cámaras nuevas cae más rápido</a:t>
             </a:r>
             <a:endParaRPr lang="en-US" sz="1700" dirty="0"/>
           </a:p>
@@ -10232,165 +10606,42 @@
                   <a:srgbClr val="222222"/>
                 </a:solidFill>
               </a:rPr>
-              <a:t>150 cajas por split (semilla fija, sin car), imágenes a resolución completa. 50 re-etiquetadas a ciegas → κ de Cohen.</a:t>
+              <a:t>150 cajas por split, resolución completa. Etiquetado inicial con un modelo de visión; 50 re-etiquetadas a ciegas por una persona → κ de Cohen.</a:t>
             </a:r>
             <a:endParaRPr lang="en-US" sz="1300" dirty="0"/>
           </a:p>
         </p:txBody>
       </p:sp>
-      <p:sp>
-        <p:nvSpPr>
-          <p:cNvPr id="19" name="Shape 16"/>
+      <p:graphicFrame>
+        <p:nvGraphicFramePr>
+          <p:cNvPr id="19" name="Chart 0" descr=""/>
+          <p:cNvGraphicFramePr/>
+          <p:nvPr/>
+        </p:nvGraphicFramePr>
+        <p:xfrm>
+          <a:off x="5943600" y="1554480"/>
+          <a:ext cx="5696712" cy="3429000"/>
+        </p:xfrm>
+        <a:graphic xmlns:a="http://schemas.openxmlformats.org/drawingml/2006/main">
+          <a:graphicData uri="http://schemas.openxmlformats.org/drawingml/2006/chart">
+            <c:chart xmlns:c="http://schemas.openxmlformats.org/drawingml/2006/chart" r:id="rId1"/>
+          </a:graphicData>
+        </a:graphic>
+      </p:graphicFrame>
+      <p:sp>
+        <p:nvSpPr>
+          <p:cNvPr id="20" name="Shape 16"/>
           <p:cNvSpPr/>
           <p:nvPr/>
         </p:nvSpPr>
         <p:spPr>
           <a:xfrm>
-            <a:off x="5943600" y="1691640"/>
-            <a:ext cx="5696712" cy="1600200"/>
+            <a:off x="5943600" y="5120640"/>
+            <a:ext cx="5696712" cy="1005840"/>
           </a:xfrm>
           <a:prstGeom prst="roundRect">
             <a:avLst>
-              <a:gd name="adj" fmla="val 4571"/>
-            </a:avLst>
-          </a:prstGeom>
-          <a:solidFill>
-            <a:srgbClr val="262A33"/>
-          </a:solidFill>
-          <a:ln w="9525">
-            <a:solidFill>
-              <a:srgbClr val="262A33"/>
-            </a:solidFill>
-            <a:prstDash val="solid"/>
-          </a:ln>
-        </p:spPr>
-      </p:sp>
-      <p:sp>
-        <p:nvSpPr>
-          <p:cNvPr id="20" name="Text 17"/>
-          <p:cNvSpPr txBox="1"/>
-          <p:nvPr/>
-        </p:nvSpPr>
-        <p:spPr>
-          <a:xfrm>
-            <a:off x="6126480" y="1764792"/>
-            <a:ext cx="5330952" cy="274320"/>
-          </a:xfrm>
-          <a:prstGeom prst="rect">
-            <a:avLst/>
-          </a:prstGeom>
-          <a:noFill/>
-          <a:ln/>
-        </p:spPr>
-        <p:txBody>
-          <a:bodyPr wrap="square" lIns="0" tIns="0" rIns="0" bIns="0" rtlCol="0" anchor="ctr"/>
-          <a:lstStyle/>
-          <a:p>
-            <a:pPr indent="0" marL="0">
-              <a:buNone/>
-            </a:pPr>
-            <a:r>
-              <a:rPr lang="en-US" sz="1000" b="1" dirty="0">
-                <a:solidFill>
-                  <a:srgbClr val="FFFFFF"/>
-                </a:solidFill>
-                <a:latin typeface="Consolas" pitchFamily="34" charset="0"/>
-                <a:ea typeface="Consolas" pitchFamily="34" charset="-122"/>
-                <a:cs typeface="Consolas" pitchFamily="34" charset="-120"/>
-              </a:rPr>
-              <a:t>Terminal</a:t>
-            </a:r>
-            <a:endParaRPr lang="en-US" sz="1000" dirty="0"/>
-          </a:p>
-        </p:txBody>
-      </p:sp>
-      <p:sp>
-        <p:nvSpPr>
-          <p:cNvPr id="21" name="Text 18"/>
-          <p:cNvSpPr txBox="1"/>
-          <p:nvPr/>
-        </p:nvSpPr>
-        <p:spPr>
-          <a:xfrm>
-            <a:off x="6126480" y="2075688"/>
-            <a:ext cx="5330952" cy="1097280"/>
-          </a:xfrm>
-          <a:prstGeom prst="rect">
-            <a:avLst/>
-          </a:prstGeom>
-          <a:noFill/>
-          <a:ln/>
-        </p:spPr>
-        <p:txBody>
-          <a:bodyPr wrap="square" lIns="0" tIns="0" rIns="0" bIns="0" rtlCol="0" anchor="t"/>
-          <a:lstStyle/>
-          <a:p>
-            <a:pPr indent="0" marL="0">
-              <a:buNone/>
-            </a:pPr>
-            <a:r>
-              <a:rPr lang="en-US" sz="1100" dirty="0">
-                <a:solidFill>
-                  <a:srgbClr val="E6E6E6"/>
-                </a:solidFill>
-                <a:latin typeface="Consolas" pitchFamily="34" charset="0"/>
-                <a:ea typeface="Consolas" pitchFamily="34" charset="-122"/>
-                <a:cs typeface="Consolas" pitchFamily="34" charset="-120"/>
-              </a:rPr>
-              <a:t>python src/etiquetar_oclusion.py</a:t>
-            </a:r>
-            <a:endParaRPr lang="en-US" sz="1100" dirty="0"/>
-          </a:p>
-          <a:p>
-            <a:pPr indent="0" marL="0">
-              <a:buNone/>
-            </a:pPr>
-            <a:r>
-              <a:rPr lang="en-US" sz="1100" dirty="0">
-                <a:solidFill>
-                  <a:srgbClr val="E6E6E6"/>
-                </a:solidFill>
-                <a:latin typeface="Consolas" pitchFamily="34" charset="0"/>
-                <a:ea typeface="Consolas" pitchFamily="34" charset="-122"/>
-                <a:cs typeface="Consolas" pitchFamily="34" charset="-120"/>
-              </a:rPr>
-              <a:t>python src/etiquetar_oclusion.py --repetir 50</a:t>
-            </a:r>
-            <a:endParaRPr lang="en-US" sz="1100" dirty="0"/>
-          </a:p>
-          <a:p>
-            <a:pPr indent="0" marL="0">
-              <a:buNone/>
-            </a:pPr>
-            <a:r>
-              <a:rPr lang="en-US" sz="1100" dirty="0">
-                <a:solidFill>
-                  <a:srgbClr val="E6E6E6"/>
-                </a:solidFill>
-                <a:latin typeface="Consolas" pitchFamily="34" charset="0"/>
-                <a:ea typeface="Consolas" pitchFamily="34" charset="-122"/>
-                <a:cs typeface="Consolas" pitchFamily="34" charset="-120"/>
-              </a:rPr>
-              <a:t>python src/tamano_oclusion.py --pred predicciones.csv</a:t>
-            </a:r>
-            <a:endParaRPr lang="en-US" sz="1100" dirty="0"/>
-          </a:p>
-        </p:txBody>
-      </p:sp>
-      <p:sp>
-        <p:nvSpPr>
-          <p:cNvPr id="22" name="Shape 19"/>
-          <p:cNvSpPr/>
-          <p:nvPr/>
-        </p:nvSpPr>
-        <p:spPr>
-          <a:xfrm>
-            <a:off x="5943600" y="3474720"/>
-            <a:ext cx="5696712" cy="2651760"/>
-          </a:xfrm>
-          <a:prstGeom prst="roundRect">
-            <a:avLst>
-              <a:gd name="adj" fmla="val 2759"/>
+              <a:gd name="adj" fmla="val 7273"/>
             </a:avLst>
           </a:prstGeom>
           <a:solidFill>
@@ -10406,14 +10657,14 @@
       </p:sp>
       <p:sp>
         <p:nvSpPr>
-          <p:cNvPr id="23" name="Text 20"/>
-          <p:cNvSpPr txBox="1"/>
-          <p:nvPr/>
-        </p:nvSpPr>
-        <p:spPr>
-          <a:xfrm>
-            <a:off x="6126480" y="3584448"/>
-            <a:ext cx="5330952" cy="2432304"/>
+          <p:cNvPr id="21" name="Text 17"/>
+          <p:cNvSpPr txBox="1"/>
+          <p:nvPr/>
+        </p:nvSpPr>
+        <p:spPr>
+          <a:xfrm>
+            <a:off x="6126480" y="5230368"/>
+            <a:ext cx="5330952" cy="786384"/>
           </a:xfrm>
           <a:prstGeom prst="rect">
             <a:avLst/>
@@ -10432,14 +10683,14 @@
               <a:buNone/>
             </a:pPr>
             <a:r>
-              <a:rPr lang="en-US" sz="1400" b="1" dirty="0">
+              <a:rPr lang="en-US" sz="1300" b="1" dirty="0">
                 <a:solidFill>
                   <a:srgbClr val="B26A00"/>
                 </a:solidFill>
               </a:rPr>
-              <a:t>Resultados del etiquetado</a:t>
-            </a:r>
-            <a:endParaRPr lang="en-US" sz="1400" dirty="0"/>
+              <a:t>Lectura</a:t>
+            </a:r>
+            <a:endParaRPr lang="en-US" sz="1300" dirty="0"/>
           </a:p>
           <a:p>
             <a:pPr indent="0" marL="0">
@@ -10449,82 +10700,14 @@
               <a:buNone/>
             </a:pPr>
             <a:r>
-              <a:rPr lang="en-US" sz="1300" dirty="0">
+              <a:rPr lang="en-US" sz="1200" dirty="0">
                 <a:solidFill>
                   <a:srgbClr val="222222"/>
                 </a:solidFill>
               </a:rPr>
-              <a:t>Recall por nivel de oclusión (cis / trans):</a:t>
-            </a:r>
-            <a:endParaRPr lang="en-US" sz="1400" dirty="0"/>
-          </a:p>
-          <a:p>
-            <a:pPr indent="0" marL="0">
-              <a:spcAft>
-                <a:spcPts val="400"/>
-              </a:spcAft>
-              <a:buNone/>
-            </a:pPr>
-            <a:r>
-              <a:rPr lang="en-US" sz="1300" dirty="0">
-                <a:solidFill>
-                  <a:srgbClr val="222222"/>
-                </a:solidFill>
-              </a:rPr>
-              <a:t>• Baja: [completar]</a:t>
-            </a:r>
-            <a:endParaRPr lang="en-US" sz="1400" dirty="0"/>
-          </a:p>
-          <a:p>
-            <a:pPr indent="0" marL="0">
-              <a:spcAft>
-                <a:spcPts val="400"/>
-              </a:spcAft>
-              <a:buNone/>
-            </a:pPr>
-            <a:r>
-              <a:rPr lang="en-US" sz="1300" dirty="0">
-                <a:solidFill>
-                  <a:srgbClr val="222222"/>
-                </a:solidFill>
-              </a:rPr>
-              <a:t>• Media: [completar]</a:t>
-            </a:r>
-            <a:endParaRPr lang="en-US" sz="1400" dirty="0"/>
-          </a:p>
-          <a:p>
-            <a:pPr indent="0" marL="0">
-              <a:spcAft>
-                <a:spcPts val="400"/>
-              </a:spcAft>
-              <a:buNone/>
-            </a:pPr>
-            <a:r>
-              <a:rPr lang="en-US" sz="1300" dirty="0">
-                <a:solidFill>
-                  <a:srgbClr val="222222"/>
-                </a:solidFill>
-              </a:rPr>
-              <a:t>• Alta: [completar]</a:t>
-            </a:r>
-            <a:endParaRPr lang="en-US" sz="1400" dirty="0"/>
-          </a:p>
-          <a:p>
-            <a:pPr indent="0" marL="0">
-              <a:spcAft>
-                <a:spcPts val="400"/>
-              </a:spcAft>
-              <a:buNone/>
-            </a:pPr>
-            <a:r>
-              <a:rPr lang="en-US" sz="1300" dirty="0">
-                <a:solidFill>
-                  <a:srgbClr val="222222"/>
-                </a:solidFill>
-              </a:rPr>
-              <a:t>κ de autoconsistencia: [completar]</a:t>
-            </a:r>
-            <a:endParaRPr lang="en-US" sz="1400" dirty="0"/>
+              <a:t>Con oclusión media, cis 0,74 → trans 0,52. Los cortes del encuadre cuentan como oclusión: conecta con las cajas grandes del borde.</a:t>
+            </a:r>
+            <a:endParaRPr lang="en-US" sz="1300" dirty="0"/>
           </a:p>
         </p:txBody>
       </p:sp>

</xml_diff>

<commit_message>
Acuerdo humano del etiquetado de oclusion y leyenda corregida
- results/oclusion: re-etiquetado humano de 50 cajas y hoja de desacuerdos
- informe y diapositiva 16: kappa -0,21 con patron en espejo (0,23 leido como
  visibilidad); el analisis de oclusion pasa a ser exploratorio
- etiquetar_oclusion.py: la leyenda pregunta cuanto del animal esta tapado

Co-Authored-By: Claude Opus 5.5 <noreply@anthropic.com>
</commit_message>
<xml_diff>
--- a/presentacion/presentacion_pregunta3_grupo6.pptx
+++ b/presentacion/presentacion_pregunta3_grupo6.pptx
@@ -4414,7 +4414,7 @@
           <a:p>
             <a:r>
               <a:rPr lang="en-US" dirty="0"/>
-              <a:t>CCT-20 no trae información de oclusión, así que armamos una muestra de 150 cajas por split y le asignamos a cada una un nivel según qué parte del animal no se ve. Por tiempo, el etiquetado inicial lo hizo un modelo de visión siguiendo el criterio, y una persona re-etiqueta 50 cajas a ciegas para medir el acuerdo. El resultado es claro: con oclusión baja el recall es 0,91 en cis y 0,82 en trans; con oclusión media cae a 0,74 y 0,52. Ver solo una parte del animal ya es difícil, y en una cámara nueva lo es mucho más. La oclusión alta tiene muy pocos casos, solo marca la tendencia.</a:t>
+              <a:t>CCT-20 no trae información de oclusión, así que armamos una muestra de 150 cajas por split y le asignamos a cada una un nivel según qué parte del animal no se ve. Por tiempo, el etiquetado inicial lo hizo un modelo de visión siguiendo el criterio, y una persona re-etiqueta 50 cajas a ciegas para medir el acuerdo. El resultado es claro: con oclusión baja el recall es 0,91 en cis y 0,82 en trans; con oclusión media cae a 0,74 y 0,52. Ver solo una parte del animal ya es difícil, y en una cámara nueva lo es mucho más. Pero hay que ser honestos con la fiabilidad: cuando una persona re-etiquetó 50 cajas, el acuerdo salió en espejo, porque la leyenda de la herramienta no decía si el porcentaje era de lo que se ve o de lo que está tapado. Leída como visibilidad, el kappa es 0,23. Por eso presentamos este análisis como exploratorio: la tendencia coincide con la del tamaño y los bordes, pero no la usamos para conclusiones firmes.</a:t>
             </a:r>
             <a:endParaRPr lang="en-US" dirty="0"/>
           </a:p>
@@ -10118,7 +10118,7 @@
                 <a:ea typeface="Cambria" pitchFamily="34" charset="-122"/>
                 <a:cs typeface="Cambria" pitchFamily="34" charset="-120"/>
               </a:rPr>
-              <a:t>E4 · Cuanto más oculto el animal, peor; y en cámaras nuevas cae más rápido</a:t>
+              <a:t>E4 · Más oclusión, menos recall (exploratorio: etiquetado poco fiable)</a:t>
             </a:r>
             <a:endParaRPr lang="en-US" sz="1700" dirty="0"/>
           </a:p>
@@ -10546,11 +10546,11 @@
             </a:avLst>
           </a:prstGeom>
           <a:solidFill>
-            <a:srgbClr val="F3F4F6"/>
+            <a:srgbClr val="F6E4E4"/>
           </a:solidFill>
           <a:ln w="9525">
             <a:solidFill>
-              <a:srgbClr val="D9D9D9"/>
+              <a:srgbClr val="F2B8B8"/>
             </a:solidFill>
             <a:prstDash val="solid"/>
           </a:ln>
@@ -10589,7 +10589,7 @@
                   <a:srgbClr val="7A1518"/>
                 </a:solidFill>
               </a:rPr>
-              <a:t>Protocolo</a:t>
+              <a:t>Fiabilidad: análisis exploratorio</a:t>
             </a:r>
             <a:endParaRPr lang="en-US" sz="1300" dirty="0"/>
           </a:p>
@@ -10606,7 +10606,7 @@
                   <a:srgbClr val="222222"/>
                 </a:solidFill>
               </a:rPr>
-              <a:t>150 cajas por split, resolución completa. Etiquetado inicial con un modelo de visión; 50 re-etiquetadas a ciegas por una persona → κ de Cohen.</a:t>
+              <a:t>Etiquetado inicial con un modelo de visión; una persona re-etiquetó 50 a ciegas. κ = −0,21 con patrón en espejo (escala leída al revés); leída como visibilidad, κ = 0,23.</a:t>
             </a:r>
             <a:endParaRPr lang="en-US" sz="1300" dirty="0"/>
           </a:p>

</xml_diff>

<commit_message>
README de verificacion: cada cifra del informe con su archivo y comando
- results/: CSV de todos los analisis (evaluacion, desbalance, borrado, EigenCAM,
  tamano/oclusion, monitoreo y verificaciones)
- src/verificaciones.py: Spearman con p-valor, concentracion por camara, cajas del
  borde y acuerdo de oclusion; incluido en run_all.py
- src/falsos_disparos_val.py: falsos disparos de E3 en validacion
- README con tres niveles de verificacion y notas para quien revise
- informe y diapositiva 12: correlacion de concentracion con valores exactos (0,35)

Co-Authored-By: Claude Opus 5.5 <noreply@anthropic.com>
</commit_message>
<xml_diff>
--- a/presentacion/presentacion_pregunta3_grupo6.pptx
+++ b/presentacion/presentacion_pregunta3_grupo6.pptx
@@ -4062,7 +4062,7 @@
           <a:p>
             <a:r>
               <a:rPr lang="en-US" dirty="0"/>
-              <a:t>Medimos qué fracción de las cajas de cada especie viene de sus dos cámaras principales. Las tres especies que más caen, roedor, gato y ave, son las más concentradas: el modelo las vio casi siempre sobre el mismo fondo. Pero la correlación con las once especies es débil, 0,33. Ardilla está repartida y cae igual. No basta para afirmar que aprendió el fondo; por eso hicimos las dos pruebas siguientes.</a:t>
+              <a:t>Medimos qué fracción de las cajas de cada especie viene de sus dos cámaras principales. Las tres especies que más caen, roedor, gato y ave, son las más concentradas: el modelo las vio casi siempre sobre el mismo fondo. Pero la correlación con las once especies es débil, 0,35. Ardilla está repartida y cae igual. No basta para afirmar que aprendió el fondo; por eso hicimos las dos pruebas siguientes.</a:t>
             </a:r>
             <a:endParaRPr lang="en-US" dirty="0"/>
           </a:p>
@@ -7963,7 +7963,7 @@
                   <a:srgbClr val="222222"/>
                 </a:solidFill>
               </a:rPr>
-              <a:t>ρ = 0,33 (p = 0,32) con 11 especies. Ardilla está repartida y cae 43 puntos.</a:t>
+              <a:t>ρ = 0,35 (p = 0,30) con 11 especies. Ardilla está repartida y cae 43 puntos.</a:t>
             </a:r>
             <a:endParaRPr lang="en-US" sz="1300" dirty="0"/>
           </a:p>

</xml_diff>